<commit_message>
Updated Day 3 items
</commit_message>
<xml_diff>
--- a/Day4/Mastering_Interview.pptx
+++ b/Day4/Mastering_Interview.pptx
@@ -5,7 +5,7 @@
     <p:sldMasterId id="2147483648" r:id="rId1"/>
   </p:sldMasterIdLst>
   <p:notesMasterIdLst>
-    <p:notesMasterId r:id="rId22"/>
+    <p:notesMasterId r:id="rId21"/>
   </p:notesMasterIdLst>
   <p:sldIdLst>
     <p:sldId id="257" r:id="rId2"/>
@@ -20,14 +20,13 @@
     <p:sldId id="310" r:id="rId11"/>
     <p:sldId id="261" r:id="rId12"/>
     <p:sldId id="262" r:id="rId13"/>
-    <p:sldId id="275" r:id="rId14"/>
-    <p:sldId id="279" r:id="rId15"/>
-    <p:sldId id="312" r:id="rId16"/>
-    <p:sldId id="313" r:id="rId17"/>
-    <p:sldId id="314" r:id="rId18"/>
-    <p:sldId id="315" r:id="rId19"/>
-    <p:sldId id="316" r:id="rId20"/>
-    <p:sldId id="280" r:id="rId21"/>
+    <p:sldId id="279" r:id="rId14"/>
+    <p:sldId id="312" r:id="rId15"/>
+    <p:sldId id="313" r:id="rId16"/>
+    <p:sldId id="314" r:id="rId17"/>
+    <p:sldId id="315" r:id="rId18"/>
+    <p:sldId id="316" r:id="rId19"/>
+    <p:sldId id="280" r:id="rId20"/>
   </p:sldIdLst>
   <p:sldSz cx="12192000" cy="6858000"/>
   <p:notesSz cx="6858000" cy="9144000"/>
@@ -1014,110 +1013,6 @@
       <p:sp>
         <p:nvSpPr>
           <p:cNvPr id="168" name="Google Shape;168;g3f00237150d_35_0:notes"/>
-          <p:cNvSpPr txBox="1">
-            <a:spLocks noGrp="1"/>
-          </p:cNvSpPr>
-          <p:nvPr>
-            <p:ph type="body" idx="1"/>
-          </p:nvPr>
-        </p:nvSpPr>
-        <p:spPr>
-          <a:xfrm>
-            <a:off x="685800" y="4343400"/>
-            <a:ext cx="5486400" cy="4114800"/>
-          </a:xfrm>
-          <a:prstGeom prst="rect">
-            <a:avLst/>
-          </a:prstGeom>
-        </p:spPr>
-        <p:txBody>
-          <a:bodyPr spcFirstLastPara="1" wrap="square" lIns="91425" tIns="91425" rIns="91425" bIns="91425" anchor="t" anchorCtr="0">
-            <a:noAutofit/>
-          </a:bodyPr>
-          <a:lstStyle/>
-          <a:p>
-            <a:pPr marL="0" lvl="0" indent="0" algn="l" rtl="0">
-              <a:spcBef>
-                <a:spcPts val="0"/>
-              </a:spcBef>
-              <a:spcAft>
-                <a:spcPts val="0"/>
-              </a:spcAft>
-              <a:buNone/>
-            </a:pPr>
-            <a:endParaRPr/>
-          </a:p>
-        </p:txBody>
-      </p:sp>
-    </p:spTree>
-  </p:cSld>
-  <p:clrMapOvr>
-    <a:masterClrMapping/>
-  </p:clrMapOvr>
-</p:notes>
-</file>
-
-<file path=ppt/notesSlides/notesSlide13.xml><?xml version="1.0" encoding="utf-8"?>
-<p:notes xmlns:a="http://schemas.openxmlformats.org/drawingml/2006/main" xmlns:r="http://schemas.openxmlformats.org/officeDocument/2006/relationships" xmlns:p="http://schemas.openxmlformats.org/presentationml/2006/main" showMasterSp="0" showMasterPhAnim="0">
-  <p:cSld>
-    <p:spTree>
-      <p:nvGrpSpPr>
-        <p:cNvPr id="1" name="Shape 615"/>
-        <p:cNvGrpSpPr/>
-        <p:nvPr/>
-      </p:nvGrpSpPr>
-      <p:grpSpPr>
-        <a:xfrm>
-          <a:off x="0" y="0"/>
-          <a:ext cx="0" cy="0"/>
-          <a:chOff x="0" y="0"/>
-          <a:chExt cx="0" cy="0"/>
-        </a:xfrm>
-      </p:grpSpPr>
-      <p:sp>
-        <p:nvSpPr>
-          <p:cNvPr id="616" name="Google Shape;616;g3f00237150d_20_0:notes"/>
-          <p:cNvSpPr>
-            <a:spLocks noGrp="1" noRot="1" noChangeAspect="1"/>
-          </p:cNvSpPr>
-          <p:nvPr>
-            <p:ph type="sldImg" idx="2"/>
-          </p:nvPr>
-        </p:nvSpPr>
-        <p:spPr>
-          <a:xfrm>
-            <a:off x="381000" y="685800"/>
-            <a:ext cx="6096000" cy="3429000"/>
-          </a:xfrm>
-          <a:custGeom>
-            <a:avLst/>
-            <a:gdLst/>
-            <a:ahLst/>
-            <a:cxnLst/>
-            <a:rect l="l" t="t" r="r" b="b"/>
-            <a:pathLst>
-              <a:path w="120000" h="120000" extrusionOk="0">
-                <a:moveTo>
-                  <a:pt x="0" y="0"/>
-                </a:moveTo>
-                <a:lnTo>
-                  <a:pt x="120000" y="0"/>
-                </a:lnTo>
-                <a:lnTo>
-                  <a:pt x="120000" y="120000"/>
-                </a:lnTo>
-                <a:lnTo>
-                  <a:pt x="0" y="120000"/>
-                </a:lnTo>
-                <a:close/>
-              </a:path>
-            </a:pathLst>
-          </a:custGeom>
-        </p:spPr>
-      </p:sp>
-      <p:sp>
-        <p:nvSpPr>
-          <p:cNvPr id="617" name="Google Shape;617;g3f00237150d_20_0:notes"/>
           <p:cNvSpPr txBox="1">
             <a:spLocks noGrp="1"/>
           </p:cNvSpPr>
@@ -6572,7 +6467,7 @@
         <p:spPr>
           <a:xfrm>
             <a:off x="402963" y="3905351"/>
-            <a:ext cx="11201500" cy="1938992"/>
+            <a:ext cx="11201500" cy="1631216"/>
           </a:xfrm>
           <a:prstGeom prst="rect">
             <a:avLst/>
@@ -6626,7 +6521,7 @@
             </a:pPr>
             <a:r>
               <a:rPr lang="en-US" sz="2000" dirty="0"/>
-              <a:t>What does the typical code review and onboarding path look like for a new graduate joining this specific team?</a:t>
+              <a:t>What does the onboarding path look like for a new graduate joining this specific team?</a:t>
             </a:r>
           </a:p>
         </p:txBody>
@@ -6769,7 +6664,7 @@
 </file>
 
 <file path=ppt/slides/slide11.xml><?xml version="1.0" encoding="utf-8"?>
-<p:sld xmlns:a="http://schemas.openxmlformats.org/drawingml/2006/main" xmlns:r="http://schemas.openxmlformats.org/officeDocument/2006/relationships" xmlns:p="http://schemas.openxmlformats.org/presentationml/2006/main">
+<p:sld xmlns:a="http://schemas.openxmlformats.org/drawingml/2006/main" xmlns:r="http://schemas.openxmlformats.org/officeDocument/2006/relationships" xmlns:p="http://schemas.openxmlformats.org/presentationml/2006/main" show="0">
   <p:cSld>
     <p:spTree>
       <p:nvGrpSpPr>
@@ -7180,7 +7075,7 @@
                   <a:buNone/>
                 </a:pPr>
                 <a:r>
-                  <a:rPr lang="en-GB" b="1">
+                  <a:rPr lang="en-GB" b="1" dirty="0">
                     <a:solidFill>
                       <a:srgbClr val="111827"/>
                     </a:solidFill>
@@ -7191,7 +7086,7 @@
                   </a:rPr>
                   <a:t>Inquire About the Tech Stack</a:t>
                 </a:r>
-                <a:endParaRPr b="1">
+                <a:endParaRPr b="1" dirty="0">
                   <a:solidFill>
                     <a:srgbClr val="111827"/>
                   </a:solidFill>
@@ -7212,7 +7107,7 @@
                   <a:buNone/>
                 </a:pPr>
                 <a:r>
-                  <a:rPr lang="en-GB" b="0">
+                  <a:rPr lang="en-GB" b="0" dirty="0">
                     <a:solidFill>
                       <a:srgbClr val="4B5563"/>
                     </a:solidFill>
@@ -7223,7 +7118,7 @@
                   </a:rPr>
                   <a:t>Ask specific questions about the tools, frameworks, and architecture the team uses daily.</a:t>
                 </a:r>
-                <a:endParaRPr b="0">
+                <a:endParaRPr b="0" dirty="0">
                   <a:solidFill>
                     <a:srgbClr val="4B5563"/>
                   </a:solidFill>
@@ -7644,7 +7539,7 @@
                   <a:buNone/>
                 </a:pPr>
                 <a:r>
-                  <a:rPr lang="en-GB" b="1">
+                  <a:rPr lang="en-GB" b="1" dirty="0">
                     <a:solidFill>
                       <a:srgbClr val="111827"/>
                     </a:solidFill>
@@ -7655,7 +7550,7 @@
                   </a:rPr>
                   <a:t>Understand Team Dynamics</a:t>
                 </a:r>
-                <a:endParaRPr b="1">
+                <a:endParaRPr b="1" dirty="0">
                   <a:solidFill>
                     <a:srgbClr val="111827"/>
                   </a:solidFill>
@@ -7676,7 +7571,7 @@
                   <a:buNone/>
                 </a:pPr>
                 <a:r>
-                  <a:rPr lang="en-GB" b="0">
+                  <a:rPr lang="en-GB" b="0" dirty="0">
                     <a:solidFill>
                       <a:srgbClr val="4B5563"/>
                     </a:solidFill>
@@ -7687,7 +7582,7 @@
                   </a:rPr>
                   <a:t>Ask about code review processes, mentorship opportunities, and how the engineering team collaborates on large features.</a:t>
                 </a:r>
-                <a:endParaRPr b="0">
+                <a:endParaRPr b="0" dirty="0">
                   <a:solidFill>
                     <a:srgbClr val="4B5563"/>
                   </a:solidFill>
@@ -8752,7 +8647,7 @@
   <p:cSld>
     <p:spTree>
       <p:nvGrpSpPr>
-        <p:cNvPr id="1" name="Shape 618"/>
+        <p:cNvPr id="1" name=""/>
         <p:cNvGrpSpPr/>
         <p:nvPr/>
       </p:nvGrpSpPr>
@@ -8766,503 +8661,188 @@
       </p:grpSpPr>
       <p:sp>
         <p:nvSpPr>
-          <p:cNvPr id="619" name="Google Shape;619;p33"/>
-          <p:cNvSpPr/>
+          <p:cNvPr id="3" name="TextBox 2">
+            <a:extLst>
+              <a:ext uri="{FF2B5EF4-FFF2-40B4-BE49-F238E27FC236}">
+                <a16:creationId xmlns:a16="http://schemas.microsoft.com/office/drawing/2014/main" id="{A22A1F47-86BB-D0D1-F709-7DDFA078934C}"/>
+              </a:ext>
+            </a:extLst>
+          </p:cNvPr>
+          <p:cNvSpPr txBox="1"/>
           <p:nvPr/>
         </p:nvSpPr>
         <p:spPr>
           <a:xfrm>
-            <a:off x="0" y="0"/>
-            <a:ext cx="12192000" cy="6858000"/>
+            <a:off x="518160" y="1624597"/>
+            <a:ext cx="8829040" cy="3785652"/>
           </a:xfrm>
           <a:prstGeom prst="rect">
             <a:avLst/>
           </a:prstGeom>
-          <a:solidFill>
-            <a:srgbClr val="F4F4F0"/>
-          </a:solidFill>
+          <a:noFill/>
+        </p:spPr>
+        <p:txBody>
+          <a:bodyPr wrap="square">
+            <a:spAutoFit/>
+          </a:bodyPr>
+          <a:lstStyle/>
+          <a:p>
+            <a:pPr>
+              <a:buNone/>
+            </a:pPr>
+            <a:r>
+              <a:rPr lang="en-US" sz="2400" b="1" dirty="0"/>
+              <a:t>Appearance &amp; Grooming - First Impression Matters</a:t>
+            </a:r>
+          </a:p>
+          <a:p>
+            <a:pPr>
+              <a:buNone/>
+            </a:pPr>
+            <a:endParaRPr lang="en-US" sz="2400" b="1" dirty="0"/>
+          </a:p>
+          <a:p>
+            <a:pPr>
+              <a:buNone/>
+            </a:pPr>
+            <a:r>
+              <a:rPr lang="en-US" sz="2400" dirty="0"/>
+              <a:t>✔ Dress neatly</a:t>
+            </a:r>
+            <a:br>
+              <a:rPr lang="en-US" sz="2400" dirty="0"/>
+            </a:br>
+            <a:r>
+              <a:rPr lang="en-US" sz="2400" dirty="0"/>
+              <a:t>✔ Be presentable</a:t>
+            </a:r>
+            <a:br>
+              <a:rPr lang="en-US" sz="2400" dirty="0"/>
+            </a:br>
+            <a:r>
+              <a:rPr lang="en-US" sz="2400" dirty="0"/>
+              <a:t>✔ Maintain hygiene</a:t>
+            </a:r>
+            <a:br>
+              <a:rPr lang="en-US" sz="2400" dirty="0"/>
+            </a:br>
+            <a:r>
+              <a:rPr lang="en-US" sz="2400" dirty="0"/>
+              <a:t>✔ Sit confidently</a:t>
+            </a:r>
+          </a:p>
+          <a:p>
+            <a:pPr>
+              <a:buNone/>
+            </a:pPr>
+            <a:endParaRPr lang="en-US" sz="2400" b="1" dirty="0"/>
+          </a:p>
+          <a:p>
+            <a:pPr>
+              <a:buNone/>
+            </a:pPr>
+            <a:endParaRPr lang="en-US" sz="2400" b="1" dirty="0"/>
+          </a:p>
+          <a:p>
+            <a:pPr>
+              <a:buNone/>
+            </a:pPr>
+            <a:r>
+              <a:rPr lang="en-US" sz="2400" b="1" dirty="0"/>
+              <a:t>Remember:</a:t>
+            </a:r>
+          </a:p>
+          <a:p>
+            <a:pPr>
+              <a:buNone/>
+            </a:pPr>
+            <a:r>
+              <a:rPr lang="en-US" sz="2400" dirty="0"/>
+              <a:t>Confidence is visible</a:t>
+            </a:r>
+          </a:p>
+        </p:txBody>
+      </p:sp>
+      <p:sp>
+        <p:nvSpPr>
+          <p:cNvPr id="2" name="Google Shape;183;p18">
+            <a:extLst>
+              <a:ext uri="{FF2B5EF4-FFF2-40B4-BE49-F238E27FC236}">
+                <a16:creationId xmlns:a16="http://schemas.microsoft.com/office/drawing/2014/main" id="{6F817633-8185-72A0-5543-54836DCBD662}"/>
+              </a:ext>
+            </a:extLst>
+          </p:cNvPr>
+          <p:cNvSpPr txBox="1"/>
+          <p:nvPr/>
+        </p:nvSpPr>
+        <p:spPr>
+          <a:xfrm>
+            <a:off x="508000" y="508000"/>
+            <a:ext cx="11176000" cy="762000"/>
+          </a:xfrm>
+          <a:prstGeom prst="rect">
+            <a:avLst/>
+          </a:prstGeom>
+          <a:noFill/>
           <a:ln>
             <a:noFill/>
           </a:ln>
         </p:spPr>
         <p:txBody>
-          <a:bodyPr spcFirstLastPara="1" wrap="square" lIns="0" tIns="0" rIns="0" bIns="0" anchor="ctr" anchorCtr="0">
+          <a:bodyPr spcFirstLastPara="1" wrap="square" lIns="0" tIns="0" rIns="0" bIns="0" anchor="t" anchorCtr="0">
             <a:noAutofit/>
           </a:bodyPr>
           <a:lstStyle/>
           <a:p>
-            <a:endParaRPr sz="2400"/>
+            <a:r>
+              <a:rPr lang="en-GB" sz="3200" dirty="0">
+                <a:solidFill>
+                  <a:srgbClr val="111827"/>
+                </a:solidFill>
+                <a:latin typeface="Outfit ExtraBold"/>
+                <a:ea typeface="Outfit ExtraBold"/>
+                <a:cs typeface="Outfit ExtraBold"/>
+                <a:sym typeface="Outfit ExtraBold"/>
+              </a:rPr>
+              <a:t>Navigating Face-to-Face vs. Online Interviews</a:t>
+            </a:r>
           </a:p>
         </p:txBody>
       </p:sp>
-      <p:grpSp>
-        <p:nvGrpSpPr>
-          <p:cNvPr id="620" name="Google Shape;620;p33"/>
-          <p:cNvGrpSpPr/>
+      <p:cxnSp>
+        <p:nvCxnSpPr>
+          <p:cNvPr id="4" name="Google Shape;184;p18">
+            <a:extLst>
+              <a:ext uri="{FF2B5EF4-FFF2-40B4-BE49-F238E27FC236}">
+                <a16:creationId xmlns:a16="http://schemas.microsoft.com/office/drawing/2014/main" id="{B7BC219A-609D-E988-8C43-8E28EB1268FC}"/>
+              </a:ext>
+            </a:extLst>
+          </p:cNvPr>
+          <p:cNvCxnSpPr/>
           <p:nvPr/>
-        </p:nvGrpSpPr>
-        <p:grpSpPr>
-          <a:xfrm>
-            <a:off x="508000" y="508000"/>
-            <a:ext cx="11201400" cy="762000"/>
-            <a:chOff x="381000" y="381000"/>
-            <a:chExt cx="8401050" cy="571500"/>
-          </a:xfrm>
-        </p:grpSpPr>
-        <p:sp>
-          <p:nvSpPr>
-            <p:cNvPr id="621" name="Google Shape;621;p33"/>
-            <p:cNvSpPr txBox="1"/>
-            <p:nvPr/>
-          </p:nvSpPr>
-          <p:spPr>
-            <a:xfrm>
-              <a:off x="381000" y="381000"/>
-              <a:ext cx="8382000" cy="571500"/>
-            </a:xfrm>
-            <a:prstGeom prst="rect">
-              <a:avLst/>
-            </a:prstGeom>
-            <a:noFill/>
-            <a:ln>
-              <a:noFill/>
-            </a:ln>
-          </p:spPr>
-          <p:txBody>
-            <a:bodyPr spcFirstLastPara="1" wrap="square" lIns="0" tIns="0" rIns="0" bIns="0" anchor="t" anchorCtr="0">
-              <a:noAutofit/>
-            </a:bodyPr>
-            <a:lstStyle/>
-            <a:p>
-              <a:r>
-                <a:rPr lang="en-GB" sz="3200">
-                  <a:solidFill>
-                    <a:srgbClr val="111827"/>
-                  </a:solidFill>
-                  <a:latin typeface="Outfit ExtraBold"/>
-                  <a:ea typeface="Outfit ExtraBold"/>
-                  <a:cs typeface="Outfit ExtraBold"/>
-                  <a:sym typeface="Outfit ExtraBold"/>
-                </a:rPr>
-                <a:t>Professional Presence</a:t>
-              </a:r>
-            </a:p>
-          </p:txBody>
-        </p:sp>
-        <p:cxnSp>
-          <p:nvCxnSpPr>
-            <p:cNvPr id="622" name="Google Shape;622;p33"/>
-            <p:cNvCxnSpPr/>
-            <p:nvPr/>
-          </p:nvCxnSpPr>
-          <p:spPr>
-            <a:xfrm>
-              <a:off x="381000" y="952500"/>
-              <a:ext cx="8382000" cy="0"/>
-            </a:xfrm>
-            <a:prstGeom prst="straightConnector1">
-              <a:avLst/>
-            </a:prstGeom>
-            <a:solidFill>
-              <a:srgbClr val="FFFFFF"/>
-            </a:solidFill>
-            <a:ln w="38100" cap="flat" cmpd="sng">
-              <a:solidFill>
-                <a:srgbClr val="111827"/>
-              </a:solidFill>
-              <a:prstDash val="solid"/>
-              <a:round/>
-              <a:headEnd type="none" w="sm" len="sm"/>
-              <a:tailEnd type="none" w="sm" len="sm"/>
-            </a:ln>
-          </p:spPr>
-        </p:cxnSp>
-        <p:sp>
-          <p:nvSpPr>
-            <p:cNvPr id="623" name="Google Shape;623;p33"/>
-            <p:cNvSpPr/>
-            <p:nvPr/>
-          </p:nvSpPr>
-          <p:spPr>
-            <a:xfrm>
-              <a:off x="8553450" y="457200"/>
-              <a:ext cx="228600" cy="228600"/>
-            </a:xfrm>
-            <a:prstGeom prst="ellipse">
-              <a:avLst/>
-            </a:prstGeom>
-            <a:solidFill>
-              <a:srgbClr val="4338CA"/>
-            </a:solidFill>
-            <a:ln w="19050" cap="flat" cmpd="sng">
-              <a:solidFill>
-                <a:srgbClr val="111827"/>
-              </a:solidFill>
-              <a:prstDash val="solid"/>
-              <a:round/>
-              <a:headEnd type="none" w="sm" len="sm"/>
-              <a:tailEnd type="none" w="sm" len="sm"/>
-            </a:ln>
-          </p:spPr>
-          <p:txBody>
-            <a:bodyPr spcFirstLastPara="1" wrap="square" lIns="0" tIns="0" rIns="0" bIns="0" anchor="ctr" anchorCtr="0">
-              <a:noAutofit/>
-            </a:bodyPr>
-            <a:lstStyle/>
-            <a:p>
-              <a:endParaRPr sz="2400"/>
-            </a:p>
-          </p:txBody>
-        </p:sp>
-      </p:grpSp>
-      <p:grpSp>
-        <p:nvGrpSpPr>
-          <p:cNvPr id="624" name="Google Shape;624;p33"/>
-          <p:cNvGrpSpPr/>
-          <p:nvPr/>
-        </p:nvGrpSpPr>
-        <p:grpSpPr>
-          <a:xfrm>
-            <a:off x="508000" y="1651000"/>
-            <a:ext cx="5537400" cy="4648200"/>
-            <a:chOff x="0" y="0"/>
-            <a:chExt cx="4153050" cy="3486150"/>
-          </a:xfrm>
-        </p:grpSpPr>
-        <p:sp>
-          <p:nvSpPr>
-            <p:cNvPr id="625" name="Google Shape;625;p33"/>
-            <p:cNvSpPr/>
-            <p:nvPr/>
-          </p:nvSpPr>
-          <p:spPr>
-            <a:xfrm>
-              <a:off x="57150" y="57150"/>
-              <a:ext cx="4095900" cy="3429000"/>
-            </a:xfrm>
-            <a:prstGeom prst="roundRect">
-              <a:avLst>
-                <a:gd name="adj" fmla="val 4444"/>
-              </a:avLst>
-            </a:prstGeom>
+        </p:nvCxnSpPr>
+        <p:spPr>
+          <a:xfrm>
+            <a:off x="508000" y="1270000"/>
+            <a:ext cx="11176000" cy="0"/>
+          </a:xfrm>
+          <a:prstGeom prst="straightConnector1">
+            <a:avLst/>
+          </a:prstGeom>
+          <a:solidFill>
+            <a:srgbClr val="FFFFFF"/>
+          </a:solidFill>
+          <a:ln w="38100" cap="flat" cmpd="sng">
             <a:solidFill>
               <a:srgbClr val="111827"/>
             </a:solidFill>
-            <a:ln>
-              <a:noFill/>
-            </a:ln>
-          </p:spPr>
-          <p:txBody>
-            <a:bodyPr spcFirstLastPara="1" wrap="square" lIns="0" tIns="0" rIns="0" bIns="0" anchor="ctr" anchorCtr="0">
-              <a:noAutofit/>
-            </a:bodyPr>
-            <a:lstStyle/>
-            <a:p>
-              <a:endParaRPr sz="2400"/>
-            </a:p>
-          </p:txBody>
-        </p:sp>
-        <p:sp>
-          <p:nvSpPr>
-            <p:cNvPr id="626" name="Google Shape;626;p33"/>
-            <p:cNvSpPr/>
-            <p:nvPr/>
-          </p:nvSpPr>
-          <p:spPr>
-            <a:xfrm>
-              <a:off x="0" y="0"/>
-              <a:ext cx="4095900" cy="3429000"/>
-            </a:xfrm>
-            <a:prstGeom prst="roundRect">
-              <a:avLst>
-                <a:gd name="adj" fmla="val 4444"/>
-              </a:avLst>
-            </a:prstGeom>
-            <a:solidFill>
-              <a:srgbClr val="FFFFFF"/>
-            </a:solidFill>
-            <a:ln w="28575" cap="flat" cmpd="sng">
-              <a:solidFill>
-                <a:srgbClr val="111827"/>
-              </a:solidFill>
-              <a:prstDash val="solid"/>
-              <a:round/>
-              <a:headEnd type="none" w="sm" len="sm"/>
-              <a:tailEnd type="none" w="sm" len="sm"/>
-            </a:ln>
-          </p:spPr>
-          <p:txBody>
-            <a:bodyPr spcFirstLastPara="1" wrap="square" lIns="0" tIns="0" rIns="0" bIns="0" anchor="ctr" anchorCtr="0">
-              <a:noAutofit/>
-            </a:bodyPr>
-            <a:lstStyle/>
-            <a:p>
-              <a:endParaRPr sz="2400"/>
-            </a:p>
-          </p:txBody>
-        </p:sp>
-        <p:sp>
-          <p:nvSpPr>
-            <p:cNvPr id="627" name="Google Shape;627;p33"/>
-            <p:cNvSpPr txBox="1"/>
-            <p:nvPr/>
-          </p:nvSpPr>
-          <p:spPr>
-            <a:xfrm>
-              <a:off x="285750" y="285750"/>
-              <a:ext cx="3524400" cy="2857500"/>
-            </a:xfrm>
-            <a:prstGeom prst="rect">
-              <a:avLst/>
-            </a:prstGeom>
-            <a:noFill/>
-            <a:ln>
-              <a:noFill/>
-            </a:ln>
-          </p:spPr>
-          <p:txBody>
-            <a:bodyPr spcFirstLastPara="1" wrap="square" lIns="0" tIns="0" rIns="0" bIns="0" anchor="t" anchorCtr="0">
-              <a:noAutofit/>
-            </a:bodyPr>
-            <a:lstStyle/>
-            <a:p>
-              <a:r>
-                <a:rPr lang="en-GB" sz="2000" b="1">
-                  <a:solidFill>
-                    <a:srgbClr val="111827"/>
-                  </a:solidFill>
-                  <a:latin typeface="Outfit"/>
-                  <a:ea typeface="Outfit"/>
-                  <a:cs typeface="Outfit"/>
-                  <a:sym typeface="Outfit"/>
-                </a:rPr>
-                <a:t>Grooming, Attire, &amp; First Impressions</a:t>
-              </a:r>
-              <a:endParaRPr sz="2000" b="1">
-                <a:solidFill>
-                  <a:srgbClr val="111827"/>
-                </a:solidFill>
-                <a:latin typeface="Outfit"/>
-                <a:ea typeface="Outfit"/>
-                <a:cs typeface="Outfit"/>
-                <a:sym typeface="Outfit"/>
-              </a:endParaRPr>
-            </a:p>
-            <a:p>
-              <a:pPr>
-                <a:spcBef>
-                  <a:spcPts val="1000"/>
-                </a:spcBef>
-              </a:pPr>
-              <a:r>
-                <a:rPr lang="en-GB" sz="1400">
-                  <a:solidFill>
-                    <a:srgbClr val="4B5563"/>
-                  </a:solidFill>
-                  <a:latin typeface="DM Sans Medium"/>
-                  <a:ea typeface="DM Sans Medium"/>
-                  <a:cs typeface="DM Sans Medium"/>
-                  <a:sym typeface="DM Sans Medium"/>
-                </a:rPr>
-                <a:t>Your visual presentation communicates respect for the opportunity and sets the tone for the interview.</a:t>
-              </a:r>
-              <a:endParaRPr sz="1400">
-                <a:solidFill>
-                  <a:srgbClr val="4B5563"/>
-                </a:solidFill>
-                <a:latin typeface="DM Sans Medium"/>
-                <a:ea typeface="DM Sans Medium"/>
-                <a:cs typeface="DM Sans Medium"/>
-                <a:sym typeface="DM Sans Medium"/>
-              </a:endParaRPr>
-            </a:p>
-            <a:p>
-              <a:pPr marL="609585" indent="-387764">
-                <a:spcBef>
-                  <a:spcPts val="1400"/>
-                </a:spcBef>
-                <a:buClr>
-                  <a:srgbClr val="4B5563"/>
-                </a:buClr>
-                <a:buSzPts val="975"/>
-                <a:buFont typeface="DM Sans"/>
-                <a:buChar char="●"/>
-              </a:pPr>
-              <a:r>
-                <a:rPr lang="en-GB" sz="1300" b="1">
-                  <a:solidFill>
-                    <a:srgbClr val="111827"/>
-                  </a:solidFill>
-                  <a:latin typeface="DM Sans"/>
-                  <a:ea typeface="DM Sans"/>
-                  <a:cs typeface="DM Sans"/>
-                  <a:sym typeface="DM Sans"/>
-                </a:rPr>
-                <a:t>Appropriate Attire:</a:t>
-              </a:r>
-              <a:r>
-                <a:rPr lang="en-GB" sz="1300">
-                  <a:solidFill>
-                    <a:srgbClr val="4B5563"/>
-                  </a:solidFill>
-                  <a:latin typeface="DM Sans"/>
-                  <a:ea typeface="DM Sans"/>
-                  <a:cs typeface="DM Sans"/>
-                  <a:sym typeface="DM Sans"/>
-                </a:rPr>
-                <a:t> Default to business professional (suit/tie or formal Indian wear) unless explicitly told otherwise.</a:t>
-              </a:r>
-              <a:endParaRPr sz="1300">
-                <a:solidFill>
-                  <a:srgbClr val="4B5563"/>
-                </a:solidFill>
-                <a:latin typeface="DM Sans"/>
-                <a:ea typeface="DM Sans"/>
-                <a:cs typeface="DM Sans"/>
-                <a:sym typeface="DM Sans"/>
-              </a:endParaRPr>
-            </a:p>
-            <a:p>
-              <a:pPr marL="609585" indent="-387764">
-                <a:spcBef>
-                  <a:spcPts val="1000"/>
-                </a:spcBef>
-                <a:buClr>
-                  <a:srgbClr val="4B5563"/>
-                </a:buClr>
-                <a:buSzPts val="975"/>
-                <a:buFont typeface="DM Sans"/>
-                <a:buChar char="●"/>
-              </a:pPr>
-              <a:r>
-                <a:rPr lang="en-GB" sz="1300" b="1">
-                  <a:solidFill>
-                    <a:srgbClr val="111827"/>
-                  </a:solidFill>
-                  <a:latin typeface="DM Sans"/>
-                  <a:ea typeface="DM Sans"/>
-                  <a:cs typeface="DM Sans"/>
-                  <a:sym typeface="DM Sans"/>
-                </a:rPr>
-                <a:t>Impeccable Grooming:</a:t>
-              </a:r>
-              <a:r>
-                <a:rPr lang="en-GB" sz="1300">
-                  <a:solidFill>
-                    <a:srgbClr val="4B5563"/>
-                  </a:solidFill>
-                  <a:latin typeface="DM Sans"/>
-                  <a:ea typeface="DM Sans"/>
-                  <a:cs typeface="DM Sans"/>
-                  <a:sym typeface="DM Sans"/>
-                </a:rPr>
-                <a:t> Ensure neat hair, trimmed nails, and a clean, ironed outfit.</a:t>
-              </a:r>
-              <a:endParaRPr sz="1300">
-                <a:solidFill>
-                  <a:srgbClr val="4B5563"/>
-                </a:solidFill>
-                <a:latin typeface="DM Sans"/>
-                <a:ea typeface="DM Sans"/>
-                <a:cs typeface="DM Sans"/>
-                <a:sym typeface="DM Sans"/>
-              </a:endParaRPr>
-            </a:p>
-            <a:p>
-              <a:pPr marL="609585" indent="-387764">
-                <a:spcBef>
-                  <a:spcPts val="1000"/>
-                </a:spcBef>
-                <a:buClr>
-                  <a:srgbClr val="4B5563"/>
-                </a:buClr>
-                <a:buSzPts val="975"/>
-                <a:buFont typeface="DM Sans"/>
-                <a:buChar char="●"/>
-              </a:pPr>
-              <a:r>
-                <a:rPr lang="en-GB" sz="1300" b="1">
-                  <a:solidFill>
-                    <a:srgbClr val="111827"/>
-                  </a:solidFill>
-                  <a:latin typeface="DM Sans"/>
-                  <a:ea typeface="DM Sans"/>
-                  <a:cs typeface="DM Sans"/>
-                  <a:sym typeface="DM Sans"/>
-                </a:rPr>
-                <a:t>Body Language:</a:t>
-              </a:r>
-              <a:r>
-                <a:rPr lang="en-GB" sz="1300">
-                  <a:solidFill>
-                    <a:srgbClr val="4B5563"/>
-                  </a:solidFill>
-                  <a:latin typeface="DM Sans"/>
-                  <a:ea typeface="DM Sans"/>
-                  <a:cs typeface="DM Sans"/>
-                  <a:sym typeface="DM Sans"/>
-                </a:rPr>
-                <a:t> Maintain an upright posture, offer a firm handshake (if in person), and avoid fidgeting.</a:t>
-              </a:r>
-              <a:endParaRPr sz="1300">
-                <a:solidFill>
-                  <a:srgbClr val="4B5563"/>
-                </a:solidFill>
-                <a:latin typeface="DM Sans"/>
-                <a:ea typeface="DM Sans"/>
-                <a:cs typeface="DM Sans"/>
-                <a:sym typeface="DM Sans"/>
-              </a:endParaRPr>
-            </a:p>
-            <a:p>
-              <a:pPr marL="609585" indent="-387764">
-                <a:spcBef>
-                  <a:spcPts val="1000"/>
-                </a:spcBef>
-                <a:buClr>
-                  <a:srgbClr val="4B5563"/>
-                </a:buClr>
-                <a:buSzPts val="975"/>
-                <a:buFont typeface="DM Sans"/>
-                <a:buChar char="●"/>
-              </a:pPr>
-              <a:r>
-                <a:rPr lang="en-GB" sz="1300" b="1">
-                  <a:solidFill>
-                    <a:srgbClr val="111827"/>
-                  </a:solidFill>
-                  <a:latin typeface="DM Sans"/>
-                  <a:ea typeface="DM Sans"/>
-                  <a:cs typeface="DM Sans"/>
-                  <a:sym typeface="DM Sans"/>
-                </a:rPr>
-                <a:t>The First 30 Seconds:</a:t>
-              </a:r>
-              <a:r>
-                <a:rPr lang="en-GB" sz="1300">
-                  <a:solidFill>
-                    <a:srgbClr val="4B5563"/>
-                  </a:solidFill>
-                  <a:latin typeface="DM Sans"/>
-                  <a:ea typeface="DM Sans"/>
-                  <a:cs typeface="DM Sans"/>
-                  <a:sym typeface="DM Sans"/>
-                </a:rPr>
-                <a:t> Interviewers form a subconscious bias in the first minute; a confident smile and clear greeting are crucial.</a:t>
-              </a:r>
-              <a:endParaRPr sz="1300">
-                <a:solidFill>
-                  <a:srgbClr val="4B5563"/>
-                </a:solidFill>
-                <a:latin typeface="DM Sans"/>
-                <a:ea typeface="DM Sans"/>
-                <a:cs typeface="DM Sans"/>
-                <a:sym typeface="DM Sans"/>
-              </a:endParaRPr>
-            </a:p>
-          </p:txBody>
-        </p:sp>
-      </p:grpSp>
+            <a:prstDash val="solid"/>
+            <a:round/>
+            <a:headEnd type="none" w="sm" len="sm"/>
+            <a:tailEnd type="none" w="sm" len="sm"/>
+          </a:ln>
+        </p:spPr>
+      </p:cxnSp>
       <p:grpSp>
         <p:nvGrpSpPr>
           <p:cNvPr id="628" name="Google Shape;628;p33"/>
@@ -9271,8 +8851,8 @@
         </p:nvGrpSpPr>
         <p:grpSpPr>
           <a:xfrm>
-            <a:off x="6223000" y="1651000"/>
-            <a:ext cx="5537400" cy="4165800"/>
+            <a:off x="5669280" y="2296161"/>
+            <a:ext cx="5064960" cy="3520640"/>
             <a:chOff x="0" y="0"/>
             <a:chExt cx="4153050" cy="3124350"/>
           </a:xfrm>
@@ -9350,7 +8930,7 @@
             <p:nvPr/>
           </p:nvPicPr>
           <p:blipFill rotWithShape="1">
-            <a:blip r:embed="rId3"/>
+            <a:blip r:embed="rId2"/>
             <a:srcRect t="80" b="80"/>
             <a:stretch>
               <a:fillRect/>
@@ -9415,215 +8995,6 @@
         </p:sp>
       </p:grpSp>
     </p:spTree>
-  </p:cSld>
-  <p:clrMapOvr>
-    <a:masterClrMapping/>
-  </p:clrMapOvr>
-</p:sld>
-</file>
-
-<file path=ppt/slides/slide14.xml><?xml version="1.0" encoding="utf-8"?>
-<p:sld xmlns:a="http://schemas.openxmlformats.org/drawingml/2006/main" xmlns:r="http://schemas.openxmlformats.org/officeDocument/2006/relationships" xmlns:p="http://schemas.openxmlformats.org/presentationml/2006/main">
-  <p:cSld>
-    <p:spTree>
-      <p:nvGrpSpPr>
-        <p:cNvPr id="1" name=""/>
-        <p:cNvGrpSpPr/>
-        <p:nvPr/>
-      </p:nvGrpSpPr>
-      <p:grpSpPr>
-        <a:xfrm>
-          <a:off x="0" y="0"/>
-          <a:ext cx="0" cy="0"/>
-          <a:chOff x="0" y="0"/>
-          <a:chExt cx="0" cy="0"/>
-        </a:xfrm>
-      </p:grpSpPr>
-      <p:sp>
-        <p:nvSpPr>
-          <p:cNvPr id="3" name="TextBox 2">
-            <a:extLst>
-              <a:ext uri="{FF2B5EF4-FFF2-40B4-BE49-F238E27FC236}">
-                <a16:creationId xmlns:a16="http://schemas.microsoft.com/office/drawing/2014/main" id="{A22A1F47-86BB-D0D1-F709-7DDFA078934C}"/>
-              </a:ext>
-            </a:extLst>
-          </p:cNvPr>
-          <p:cNvSpPr txBox="1"/>
-          <p:nvPr/>
-        </p:nvSpPr>
-        <p:spPr>
-          <a:xfrm>
-            <a:off x="518160" y="1624597"/>
-            <a:ext cx="8829040" cy="3785652"/>
-          </a:xfrm>
-          <a:prstGeom prst="rect">
-            <a:avLst/>
-          </a:prstGeom>
-          <a:noFill/>
-        </p:spPr>
-        <p:txBody>
-          <a:bodyPr wrap="square">
-            <a:spAutoFit/>
-          </a:bodyPr>
-          <a:lstStyle/>
-          <a:p>
-            <a:pPr>
-              <a:buNone/>
-            </a:pPr>
-            <a:r>
-              <a:rPr lang="en-US" sz="2400" b="1" dirty="0"/>
-              <a:t>Appearance &amp; Grooming - First Impression Matters</a:t>
-            </a:r>
-          </a:p>
-          <a:p>
-            <a:pPr>
-              <a:buNone/>
-            </a:pPr>
-            <a:endParaRPr lang="en-US" sz="2400" b="1" dirty="0"/>
-          </a:p>
-          <a:p>
-            <a:pPr>
-              <a:buNone/>
-            </a:pPr>
-            <a:r>
-              <a:rPr lang="en-US" sz="2400" dirty="0"/>
-              <a:t>✔ Dress neatly</a:t>
-            </a:r>
-            <a:br>
-              <a:rPr lang="en-US" sz="2400" dirty="0"/>
-            </a:br>
-            <a:r>
-              <a:rPr lang="en-US" sz="2400" dirty="0"/>
-              <a:t>✔ Be presentable</a:t>
-            </a:r>
-            <a:br>
-              <a:rPr lang="en-US" sz="2400" dirty="0"/>
-            </a:br>
-            <a:r>
-              <a:rPr lang="en-US" sz="2400" dirty="0"/>
-              <a:t>✔ Maintain hygiene</a:t>
-            </a:r>
-            <a:br>
-              <a:rPr lang="en-US" sz="2400" dirty="0"/>
-            </a:br>
-            <a:r>
-              <a:rPr lang="en-US" sz="2400" dirty="0"/>
-              <a:t>✔ Sit confidently</a:t>
-            </a:r>
-          </a:p>
-          <a:p>
-            <a:pPr>
-              <a:buNone/>
-            </a:pPr>
-            <a:endParaRPr lang="en-US" sz="2400" b="1" dirty="0"/>
-          </a:p>
-          <a:p>
-            <a:pPr>
-              <a:buNone/>
-            </a:pPr>
-            <a:endParaRPr lang="en-US" sz="2400" b="1" dirty="0"/>
-          </a:p>
-          <a:p>
-            <a:pPr>
-              <a:buNone/>
-            </a:pPr>
-            <a:r>
-              <a:rPr lang="en-US" sz="2400" b="1" dirty="0"/>
-              <a:t>Remember:</a:t>
-            </a:r>
-          </a:p>
-          <a:p>
-            <a:pPr>
-              <a:buNone/>
-            </a:pPr>
-            <a:r>
-              <a:rPr lang="en-US" sz="2400" dirty="0"/>
-              <a:t>Confidence is visible</a:t>
-            </a:r>
-          </a:p>
-        </p:txBody>
-      </p:sp>
-      <p:sp>
-        <p:nvSpPr>
-          <p:cNvPr id="2" name="Google Shape;183;p18">
-            <a:extLst>
-              <a:ext uri="{FF2B5EF4-FFF2-40B4-BE49-F238E27FC236}">
-                <a16:creationId xmlns:a16="http://schemas.microsoft.com/office/drawing/2014/main" id="{6F817633-8185-72A0-5543-54836DCBD662}"/>
-              </a:ext>
-            </a:extLst>
-          </p:cNvPr>
-          <p:cNvSpPr txBox="1"/>
-          <p:nvPr/>
-        </p:nvSpPr>
-        <p:spPr>
-          <a:xfrm>
-            <a:off x="508000" y="508000"/>
-            <a:ext cx="11176000" cy="762000"/>
-          </a:xfrm>
-          <a:prstGeom prst="rect">
-            <a:avLst/>
-          </a:prstGeom>
-          <a:noFill/>
-          <a:ln>
-            <a:noFill/>
-          </a:ln>
-        </p:spPr>
-        <p:txBody>
-          <a:bodyPr spcFirstLastPara="1" wrap="square" lIns="0" tIns="0" rIns="0" bIns="0" anchor="t" anchorCtr="0">
-            <a:noAutofit/>
-          </a:bodyPr>
-          <a:lstStyle/>
-          <a:p>
-            <a:r>
-              <a:rPr lang="en-GB" sz="3200" dirty="0">
-                <a:solidFill>
-                  <a:srgbClr val="111827"/>
-                </a:solidFill>
-                <a:latin typeface="Outfit ExtraBold"/>
-                <a:ea typeface="Outfit ExtraBold"/>
-                <a:cs typeface="Outfit ExtraBold"/>
-                <a:sym typeface="Outfit ExtraBold"/>
-              </a:rPr>
-              <a:t>Navigating Face-to-Face vs. Online Interviews</a:t>
-            </a:r>
-          </a:p>
-        </p:txBody>
-      </p:sp>
-      <p:cxnSp>
-        <p:nvCxnSpPr>
-          <p:cNvPr id="4" name="Google Shape;184;p18">
-            <a:extLst>
-              <a:ext uri="{FF2B5EF4-FFF2-40B4-BE49-F238E27FC236}">
-                <a16:creationId xmlns:a16="http://schemas.microsoft.com/office/drawing/2014/main" id="{B7BC219A-609D-E988-8C43-8E28EB1268FC}"/>
-              </a:ext>
-            </a:extLst>
-          </p:cNvPr>
-          <p:cNvCxnSpPr/>
-          <p:nvPr/>
-        </p:nvCxnSpPr>
-        <p:spPr>
-          <a:xfrm>
-            <a:off x="508000" y="1270000"/>
-            <a:ext cx="11176000" cy="0"/>
-          </a:xfrm>
-          <a:prstGeom prst="straightConnector1">
-            <a:avLst/>
-          </a:prstGeom>
-          <a:solidFill>
-            <a:srgbClr val="FFFFFF"/>
-          </a:solidFill>
-          <a:ln w="38100" cap="flat" cmpd="sng">
-            <a:solidFill>
-              <a:srgbClr val="111827"/>
-            </a:solidFill>
-            <a:prstDash val="solid"/>
-            <a:round/>
-            <a:headEnd type="none" w="sm" len="sm"/>
-            <a:tailEnd type="none" w="sm" len="sm"/>
-          </a:ln>
-        </p:spPr>
-      </p:cxnSp>
-    </p:spTree>
     <p:extLst>
       <p:ext uri="{BB962C8B-B14F-4D97-AF65-F5344CB8AC3E}">
         <p14:creationId xmlns:p14="http://schemas.microsoft.com/office/powerpoint/2010/main" val="4248713634"/>
@@ -9636,7 +9007,7 @@
 </p:sld>
 </file>
 
-<file path=ppt/slides/slide15.xml><?xml version="1.0" encoding="utf-8"?>
+<file path=ppt/slides/slide14.xml><?xml version="1.0" encoding="utf-8"?>
 <p:sld xmlns:a="http://schemas.openxmlformats.org/drawingml/2006/main" xmlns:r="http://schemas.openxmlformats.org/officeDocument/2006/relationships" xmlns:p="http://schemas.openxmlformats.org/presentationml/2006/main">
   <p:cSld>
     <p:spTree>
@@ -9873,7 +9244,7 @@
 </p:sld>
 </file>
 
-<file path=ppt/slides/slide16.xml><?xml version="1.0" encoding="utf-8"?>
+<file path=ppt/slides/slide15.xml><?xml version="1.0" encoding="utf-8"?>
 <p:sld xmlns:a="http://schemas.openxmlformats.org/drawingml/2006/main" xmlns:r="http://schemas.openxmlformats.org/officeDocument/2006/relationships" xmlns:p="http://schemas.openxmlformats.org/presentationml/2006/main">
   <p:cSld>
     <p:spTree>
@@ -10493,7 +9864,7 @@
 </p:sld>
 </file>
 
-<file path=ppt/slides/slide17.xml><?xml version="1.0" encoding="utf-8"?>
+<file path=ppt/slides/slide16.xml><?xml version="1.0" encoding="utf-8"?>
 <p:sld xmlns:a="http://schemas.openxmlformats.org/drawingml/2006/main" xmlns:r="http://schemas.openxmlformats.org/officeDocument/2006/relationships" xmlns:p="http://schemas.openxmlformats.org/presentationml/2006/main">
   <p:cSld>
     <p:spTree>
@@ -10741,7 +10112,7 @@
 </p:sld>
 </file>
 
-<file path=ppt/slides/slide18.xml><?xml version="1.0" encoding="utf-8"?>
+<file path=ppt/slides/slide17.xml><?xml version="1.0" encoding="utf-8"?>
 <p:sld xmlns:a="http://schemas.openxmlformats.org/drawingml/2006/main" xmlns:r="http://schemas.openxmlformats.org/officeDocument/2006/relationships" xmlns:p="http://schemas.openxmlformats.org/presentationml/2006/main">
   <p:cSld>
     <p:spTree>
@@ -10778,7 +10149,7 @@
         </p:nvSpPr>
         <p:spPr>
           <a:xfrm>
-            <a:off x="508000" y="1594116"/>
+            <a:off x="508000" y="1604276"/>
             <a:ext cx="10871200" cy="3785652"/>
           </a:xfrm>
           <a:prstGeom prst="rect">
@@ -10970,7 +10341,7 @@
 </p:sld>
 </file>
 
-<file path=ppt/slides/slide19.xml><?xml version="1.0" encoding="utf-8"?>
+<file path=ppt/slides/slide18.xml><?xml version="1.0" encoding="utf-8"?>
 <p:sld xmlns:a="http://schemas.openxmlformats.org/drawingml/2006/main" xmlns:r="http://schemas.openxmlformats.org/officeDocument/2006/relationships" xmlns:p="http://schemas.openxmlformats.org/presentationml/2006/main">
   <p:cSld>
     <p:spTree>
@@ -11342,6 +10713,84 @@
   <p:clrMapOvr>
     <a:masterClrMapping/>
   </p:clrMapOvr>
+</p:sld>
+</file>
+
+<file path=ppt/slides/slide19.xml><?xml version="1.0" encoding="utf-8"?>
+<p:sld xmlns:a="http://schemas.openxmlformats.org/drawingml/2006/main" xmlns:r="http://schemas.openxmlformats.org/officeDocument/2006/relationships" xmlns:p="http://schemas.openxmlformats.org/presentationml/2006/main">
+  <p:cSld>
+    <p:spTree>
+      <p:nvGrpSpPr>
+        <p:cNvPr id="1" name=""/>
+        <p:cNvGrpSpPr/>
+        <p:nvPr/>
+      </p:nvGrpSpPr>
+      <p:grpSpPr>
+        <a:xfrm>
+          <a:off x="0" y="0"/>
+          <a:ext cx="0" cy="0"/>
+          <a:chOff x="0" y="0"/>
+          <a:chExt cx="0" cy="0"/>
+        </a:xfrm>
+      </p:grpSpPr>
+      <p:sp>
+        <p:nvSpPr>
+          <p:cNvPr id="2" name="TextBox 1">
+            <a:extLst>
+              <a:ext uri="{FF2B5EF4-FFF2-40B4-BE49-F238E27FC236}">
+                <a16:creationId xmlns:a16="http://schemas.microsoft.com/office/drawing/2014/main" id="{1B1535E3-3039-77A0-8B46-8637C5119924}"/>
+              </a:ext>
+            </a:extLst>
+          </p:cNvPr>
+          <p:cNvSpPr txBox="1"/>
+          <p:nvPr/>
+        </p:nvSpPr>
+        <p:spPr>
+          <a:xfrm>
+            <a:off x="2699264" y="2981960"/>
+            <a:ext cx="6272871" cy="1569660"/>
+          </a:xfrm>
+          <a:prstGeom prst="rect">
+            <a:avLst/>
+          </a:prstGeom>
+          <a:noFill/>
+        </p:spPr>
+        <p:txBody>
+          <a:bodyPr wrap="none" rtlCol="0">
+            <a:spAutoFit/>
+          </a:bodyPr>
+          <a:lstStyle/>
+          <a:p>
+            <a:pPr algn="ctr"/>
+            <a:r>
+              <a:rPr lang="en-US" sz="9600" i="1" dirty="0"/>
+              <a:t>Thank you </a:t>
+            </a:r>
+          </a:p>
+        </p:txBody>
+      </p:sp>
+    </p:spTree>
+    <p:extLst>
+      <p:ext uri="{BB962C8B-B14F-4D97-AF65-F5344CB8AC3E}">
+        <p14:creationId xmlns:p14="http://schemas.microsoft.com/office/powerpoint/2010/main" val="1565631495"/>
+      </p:ext>
+    </p:extLst>
+  </p:cSld>
+  <p:clrMapOvr>
+    <a:masterClrMapping/>
+  </p:clrMapOvr>
+  <mc:AlternateContent xmlns:mc="http://schemas.openxmlformats.org/markup-compatibility/2006" xmlns:p14="http://schemas.microsoft.com/office/powerpoint/2010/main">
+    <mc:Choice Requires="p14">
+      <p:transition spd="med" p14:dur="700">
+        <p:fade/>
+      </p:transition>
+    </mc:Choice>
+    <mc:Fallback xmlns="">
+      <p:transition spd="med">
+        <p:fade/>
+      </p:transition>
+    </mc:Fallback>
+  </mc:AlternateContent>
 </p:sld>
 </file>
 
@@ -11917,84 +11366,6 @@
   <p:clrMapOvr>
     <a:masterClrMapping/>
   </p:clrMapOvr>
-</p:sld>
-</file>
-
-<file path=ppt/slides/slide20.xml><?xml version="1.0" encoding="utf-8"?>
-<p:sld xmlns:a="http://schemas.openxmlformats.org/drawingml/2006/main" xmlns:r="http://schemas.openxmlformats.org/officeDocument/2006/relationships" xmlns:p="http://schemas.openxmlformats.org/presentationml/2006/main">
-  <p:cSld>
-    <p:spTree>
-      <p:nvGrpSpPr>
-        <p:cNvPr id="1" name=""/>
-        <p:cNvGrpSpPr/>
-        <p:nvPr/>
-      </p:nvGrpSpPr>
-      <p:grpSpPr>
-        <a:xfrm>
-          <a:off x="0" y="0"/>
-          <a:ext cx="0" cy="0"/>
-          <a:chOff x="0" y="0"/>
-          <a:chExt cx="0" cy="0"/>
-        </a:xfrm>
-      </p:grpSpPr>
-      <p:sp>
-        <p:nvSpPr>
-          <p:cNvPr id="2" name="TextBox 1">
-            <a:extLst>
-              <a:ext uri="{FF2B5EF4-FFF2-40B4-BE49-F238E27FC236}">
-                <a16:creationId xmlns:a16="http://schemas.microsoft.com/office/drawing/2014/main" id="{1B1535E3-3039-77A0-8B46-8637C5119924}"/>
-              </a:ext>
-            </a:extLst>
-          </p:cNvPr>
-          <p:cNvSpPr txBox="1"/>
-          <p:nvPr/>
-        </p:nvSpPr>
-        <p:spPr>
-          <a:xfrm>
-            <a:off x="2699264" y="2981960"/>
-            <a:ext cx="6272871" cy="1569660"/>
-          </a:xfrm>
-          <a:prstGeom prst="rect">
-            <a:avLst/>
-          </a:prstGeom>
-          <a:noFill/>
-        </p:spPr>
-        <p:txBody>
-          <a:bodyPr wrap="none" rtlCol="0">
-            <a:spAutoFit/>
-          </a:bodyPr>
-          <a:lstStyle/>
-          <a:p>
-            <a:pPr algn="ctr"/>
-            <a:r>
-              <a:rPr lang="en-US" sz="9600" i="1" dirty="0"/>
-              <a:t>Thank you </a:t>
-            </a:r>
-          </a:p>
-        </p:txBody>
-      </p:sp>
-    </p:spTree>
-    <p:extLst>
-      <p:ext uri="{BB962C8B-B14F-4D97-AF65-F5344CB8AC3E}">
-        <p14:creationId xmlns:p14="http://schemas.microsoft.com/office/powerpoint/2010/main" val="1565631495"/>
-      </p:ext>
-    </p:extLst>
-  </p:cSld>
-  <p:clrMapOvr>
-    <a:masterClrMapping/>
-  </p:clrMapOvr>
-  <mc:AlternateContent xmlns:mc="http://schemas.openxmlformats.org/markup-compatibility/2006">
-    <mc:Choice xmlns:p14="http://schemas.microsoft.com/office/powerpoint/2010/main" Requires="p14">
-      <p:transition spd="med" p14:dur="700">
-        <p:fade/>
-      </p:transition>
-    </mc:Choice>
-    <mc:Fallback>
-      <p:transition spd="med">
-        <p:fade/>
-      </p:transition>
-    </mc:Fallback>
-  </mc:AlternateContent>
 </p:sld>
 </file>
 

</xml_diff>